<commit_message>
Fix all slide issues - sexy slides complete!
MAJOR FIXES:
✓ Slide 1: Grids now use A/B symbols instead of # (attribution clear!)
  - Robot A shows 'A' for obstacles
  - Robot B shows 'B' for obstacles
  - Union grid shows BOTH A and B - the KEY INSIGHT!
✓ Slide 1: Better PATH_CERT visualization (vertical path)
✓ Slide 1: Better CUT_CERT barrier (vertical column of blocks)

IMPROVEMENTS:
✓ Slide 2: Improved sequence diagram with box-drawing chars (┌─┐│└┘)
✓ Slide 2: Fast path emphasized (2/3 slide), conflict path smaller (1/3)
✓ Slide 3: Added grid lines to witness bits table
✓ Slide 5: CertTalk box enlarged by 20% for emphasis

Philosophy: "ASCII is elegant" - using proper Unicode symbols throughout!

All 6 slides now production-ready.

🤖 Generated with [Claude Code](https://claude.com/claude-code)

Co-Authored-By: Claude <noreply@anthropic.com>
</commit_message>
<xml_diff>
--- a/CertTalk_Presentation.pptx
+++ b/CertTalk_Presentation.pptx
@@ -3208,7 +3208,7 @@
               </a:defRPr>
             </a:pPr>
             <a:r>
-              <a:t>. . # . .</a:t>
+              <a:t>. . A . .</a:t>
             </a:r>
           </a:p>
           <a:p>
@@ -3221,7 +3221,7 @@
               </a:defRPr>
             </a:pPr>
             <a:r>
-              <a:t>. . # . .</a:t>
+              <a:t>. . A . .</a:t>
             </a:r>
           </a:p>
           <a:p>
@@ -3362,7 +3362,7 @@
               </a:defRPr>
             </a:pPr>
             <a:r>
-              <a:t>S . . # .</a:t>
+              <a:t>S . . B .</a:t>
             </a:r>
           </a:p>
           <a:p>
@@ -3388,7 +3388,7 @@
               </a:defRPr>
             </a:pPr>
             <a:r>
-              <a:t>. # . . .</a:t>
+              <a:t>. B . . .</a:t>
             </a:r>
           </a:p>
           <a:p>
@@ -3401,7 +3401,7 @@
               </a:defRPr>
             </a:pPr>
             <a:r>
-              <a:t>. . . . #</a:t>
+              <a:t>. . . . B</a:t>
             </a:r>
           </a:p>
           <a:p>
@@ -3529,7 +3529,7 @@
               </a:defRPr>
             </a:pPr>
             <a:r>
-              <a:t>S . . # .</a:t>
+              <a:t>S . . B .</a:t>
             </a:r>
           </a:p>
           <a:p>
@@ -3542,7 +3542,7 @@
               </a:defRPr>
             </a:pPr>
             <a:r>
-              <a:t>. . # . .</a:t>
+              <a:t>. . A . .</a:t>
             </a:r>
           </a:p>
           <a:p>
@@ -3555,7 +3555,7 @@
               </a:defRPr>
             </a:pPr>
             <a:r>
-              <a:t>. # # . .</a:t>
+              <a:t>. B A . .</a:t>
             </a:r>
           </a:p>
           <a:p>
@@ -3568,7 +3568,7 @@
               </a:defRPr>
             </a:pPr>
             <a:r>
-              <a:t>. . . . #</a:t>
+              <a:t>. . . . B</a:t>
             </a:r>
           </a:p>
           <a:p>
@@ -3791,7 +3791,7 @@
         <p:spPr>
           <a:xfrm>
             <a:off x="1097280" y="4572000"/>
-            <a:ext cx="2743200" cy="365760"/>
+            <a:ext cx="2743200" cy="731520"/>
           </a:xfrm>
           <a:prstGeom prst="rect">
             <a:avLst/>
@@ -3805,7 +3805,7 @@
           <a:lstStyle/>
           <a:p>
             <a:pPr algn="l">
-              <a:defRPr sz="1600" b="0">
+              <a:defRPr sz="1400" b="0">
                 <a:solidFill>
                   <a:srgbClr val="2C3E50"/>
                 </a:solidFill>
@@ -3813,7 +3813,46 @@
               </a:defRPr>
             </a:pPr>
             <a:r>
-              <a:t>S→→↓↓↓↓→→→G</a:t>
+              <a:t>S→→↓</a:t>
+            </a:r>
+          </a:p>
+          <a:p>
+            <a:pPr algn="l">
+              <a:defRPr sz="1400" b="0">
+                <a:solidFill>
+                  <a:srgbClr val="2C3E50"/>
+                </a:solidFill>
+                <a:latin typeface="Courier New"/>
+              </a:defRPr>
+            </a:pPr>
+            <a:r>
+              <a:t>   ↓</a:t>
+            </a:r>
+          </a:p>
+          <a:p>
+            <a:pPr algn="l">
+              <a:defRPr sz="1400" b="0">
+                <a:solidFill>
+                  <a:srgbClr val="2C3E50"/>
+                </a:solidFill>
+                <a:latin typeface="Courier New"/>
+              </a:defRPr>
+            </a:pPr>
+            <a:r>
+              <a:t>   ↓</a:t>
+            </a:r>
+          </a:p>
+          <a:p>
+            <a:pPr algn="l">
+              <a:defRPr sz="1400" b="0">
+                <a:solidFill>
+                  <a:srgbClr val="2C3E50"/>
+                </a:solidFill>
+                <a:latin typeface="Courier New"/>
+              </a:defRPr>
+            </a:pPr>
+            <a:r>
+              <a:t>   ↓→→→G</a:t>
             </a:r>
           </a:p>
         </p:txBody>
@@ -3826,7 +3865,7 @@
         </p:nvSpPr>
         <p:spPr>
           <a:xfrm>
-            <a:off x="1097280" y="5120640"/>
+            <a:off x="1097280" y="5394960"/>
             <a:ext cx="2743200" cy="274320"/>
           </a:xfrm>
           <a:prstGeom prst="rect">
@@ -3980,7 +4019,7 @@
         <p:spPr>
           <a:xfrm>
             <a:off x="5212080" y="4572000"/>
-            <a:ext cx="2743200" cy="365760"/>
+            <a:ext cx="2743200" cy="731520"/>
           </a:xfrm>
           <a:prstGeom prst="rect">
             <a:avLst/>
@@ -3994,15 +4033,67 @@
           <a:lstStyle/>
           <a:p>
             <a:pPr algn="l">
-              <a:defRPr sz="1800" b="0">
-                <a:solidFill>
-                  <a:srgbClr val="2C3E50"/>
-                </a:solidFill>
-                <a:latin typeface="Calibri"/>
-              </a:defRPr>
-            </a:pPr>
-            <a:r>
-              <a:t>████</a:t>
+              <a:defRPr sz="1200" b="0">
+                <a:solidFill>
+                  <a:srgbClr val="2C3E50"/>
+                </a:solidFill>
+                <a:latin typeface="Courier New"/>
+              </a:defRPr>
+            </a:pPr>
+            <a:r>
+              <a:t>. . . . .</a:t>
+            </a:r>
+          </a:p>
+          <a:p>
+            <a:pPr algn="l">
+              <a:defRPr sz="1200" b="0">
+                <a:solidFill>
+                  <a:srgbClr val="2C3E50"/>
+                </a:solidFill>
+                <a:latin typeface="Courier New"/>
+              </a:defRPr>
+            </a:pPr>
+            <a:r>
+              <a:t>. █ █ . .</a:t>
+            </a:r>
+          </a:p>
+          <a:p>
+            <a:pPr algn="l">
+              <a:defRPr sz="1200" b="0">
+                <a:solidFill>
+                  <a:srgbClr val="2C3E50"/>
+                </a:solidFill>
+                <a:latin typeface="Courier New"/>
+              </a:defRPr>
+            </a:pPr>
+            <a:r>
+              <a:t>. █ █ . .</a:t>
+            </a:r>
+          </a:p>
+          <a:p>
+            <a:pPr algn="l">
+              <a:defRPr sz="1200" b="0">
+                <a:solidFill>
+                  <a:srgbClr val="2C3E50"/>
+                </a:solidFill>
+                <a:latin typeface="Courier New"/>
+              </a:defRPr>
+            </a:pPr>
+            <a:r>
+              <a:t>. █ █ . .</a:t>
+            </a:r>
+          </a:p>
+          <a:p>
+            <a:pPr algn="l">
+              <a:defRPr sz="1200" b="0">
+                <a:solidFill>
+                  <a:srgbClr val="2C3E50"/>
+                </a:solidFill>
+                <a:latin typeface="Courier New"/>
+              </a:defRPr>
+            </a:pPr>
+            <a:r>
+              <a:t>. . . . .</a:t>
             </a:r>
           </a:p>
         </p:txBody>
@@ -4015,7 +4106,7 @@
         </p:nvSpPr>
         <p:spPr>
           <a:xfrm>
-            <a:off x="5212080" y="5120640"/>
+            <a:off x="5212080" y="5394960"/>
             <a:ext cx="2743200" cy="274320"/>
           </a:xfrm>
           <a:prstGeom prst="rect">
@@ -4104,8 +4195,8 @@
         </p:nvSpPr>
         <p:spPr>
           <a:xfrm>
-            <a:off x="1371600" y="1097280"/>
-            <a:ext cx="1828800" cy="274320"/>
+            <a:off x="457200" y="914400"/>
+            <a:ext cx="8229600" cy="274320"/>
           </a:xfrm>
           <a:prstGeom prst="rect">
             <a:avLst/>
@@ -4118,16 +4209,16 @@
           </a:bodyPr>
           <a:lstStyle/>
           <a:p>
-            <a:pPr algn="ctr">
-              <a:defRPr sz="1400" b="1">
-                <a:solidFill>
-                  <a:srgbClr val="2980B9"/>
-                </a:solidFill>
-                <a:latin typeface="Calibri"/>
-              </a:defRPr>
-            </a:pPr>
-            <a:r>
-              <a:t>AGENT A</a:t>
+            <a:pPr algn="l">
+              <a:defRPr sz="1800" b="1">
+                <a:solidFill>
+                  <a:srgbClr val="F39C12"/>
+                </a:solidFill>
+                <a:latin typeface="Calibri"/>
+              </a:defRPr>
+            </a:pPr>
+            <a:r>
+              <a:t>Fast Path (Happy Case)</a:t>
             </a:r>
           </a:p>
         </p:txBody>
@@ -4140,8 +4231,8 @@
         </p:nvSpPr>
         <p:spPr>
           <a:xfrm>
-            <a:off x="1371600" y="1371600"/>
-            <a:ext cx="1828800" cy="274320"/>
+            <a:off x="731520" y="1280160"/>
+            <a:ext cx="7680960" cy="3200400"/>
           </a:xfrm>
           <a:prstGeom prst="rect">
             <a:avLst/>
@@ -4154,16 +4245,211 @@
           </a:bodyPr>
           <a:lstStyle/>
           <a:p>
-            <a:pPr algn="ctr">
-              <a:defRPr sz="1100" b="0">
-                <a:solidFill>
-                  <a:srgbClr val="2C3E50"/>
-                </a:solidFill>
-                <a:latin typeface="Calibri"/>
-              </a:defRPr>
-            </a:pPr>
-            <a:r>
-              <a:t>(Initiator)</a:t>
+            <a:pPr algn="l">
+              <a:defRPr sz="900" b="0">
+                <a:solidFill>
+                  <a:srgbClr val="2C3E50"/>
+                </a:solidFill>
+                <a:latin typeface="Courier New"/>
+              </a:defRPr>
+            </a:pPr>
+            <a:r>
+              <a:t>┌─────────────┐                           ┌─────────────┐</a:t>
+            </a:r>
+          </a:p>
+          <a:p>
+            <a:pPr algn="l">
+              <a:defRPr sz="900" b="0">
+                <a:solidFill>
+                  <a:srgbClr val="2C3E50"/>
+                </a:solidFill>
+                <a:latin typeface="Courier New"/>
+              </a:defRPr>
+            </a:pPr>
+            <a:r>
+              <a:t>│   AGENT A   │                           │   AGENT B   │</a:t>
+            </a:r>
+          </a:p>
+          <a:p>
+            <a:pPr algn="l">
+              <a:defRPr sz="900" b="0">
+                <a:solidFill>
+                  <a:srgbClr val="2C3E50"/>
+                </a:solidFill>
+                <a:latin typeface="Courier New"/>
+              </a:defRPr>
+            </a:pPr>
+            <a:r>
+              <a:t>│ (Initiator) │                           │ (Responder) │</a:t>
+            </a:r>
+          </a:p>
+          <a:p>
+            <a:pPr algn="l">
+              <a:defRPr sz="900" b="0">
+                <a:solidFill>
+                  <a:srgbClr val="2C3E50"/>
+                </a:solidFill>
+                <a:latin typeface="Courier New"/>
+              </a:defRPr>
+            </a:pPr>
+            <a:r>
+              <a:t>└──────┬──────┘                           └──────┬──────┘</a:t>
+            </a:r>
+          </a:p>
+          <a:p>
+            <a:pPr algn="l">
+              <a:defRPr sz="900" b="0">
+                <a:solidFill>
+                  <a:srgbClr val="2C3E50"/>
+                </a:solidFill>
+                <a:latin typeface="Courier New"/>
+              </a:defRPr>
+            </a:pPr>
+            <a:r>
+              <a:t>       │                                         │</a:t>
+            </a:r>
+          </a:p>
+          <a:p>
+            <a:pPr algn="l">
+              <a:defRPr sz="900" b="0">
+                <a:solidFill>
+                  <a:srgbClr val="2C3E50"/>
+                </a:solidFill>
+                <a:latin typeface="Courier New"/>
+              </a:defRPr>
+            </a:pPr>
+            <a:r>
+              <a:t>       │  PATH_PROPOSE "Try route: ↓↓↓→→→"      │</a:t>
+            </a:r>
+          </a:p>
+          <a:p>
+            <a:pPr algn="l">
+              <a:defRPr sz="900" b="0">
+                <a:solidFill>
+                  <a:srgbClr val="2C3E50"/>
+                </a:solidFill>
+                <a:latin typeface="Courier New"/>
+              </a:defRPr>
+            </a:pPr>
+            <a:r>
+              <a:t>       ├────────────────────────────────────────&gt;│</a:t>
+            </a:r>
+          </a:p>
+          <a:p>
+            <a:pPr algn="l">
+              <a:defRPr sz="900" b="0">
+                <a:solidFill>
+                  <a:srgbClr val="2C3E50"/>
+                </a:solidFill>
+                <a:latin typeface="Courier New"/>
+              </a:defRPr>
+            </a:pPr>
+            <a:r>
+              <a:t>       │                                         │ Check against</a:t>
+            </a:r>
+          </a:p>
+          <a:p>
+            <a:pPr algn="l">
+              <a:defRPr sz="900" b="0">
+                <a:solidFill>
+                  <a:srgbClr val="2C3E50"/>
+                </a:solidFill>
+                <a:latin typeface="Courier New"/>
+              </a:defRPr>
+            </a:pPr>
+            <a:r>
+              <a:t>       │                                         │ private map</a:t>
+            </a:r>
+          </a:p>
+          <a:p>
+            <a:pPr algn="l">
+              <a:defRPr sz="900" b="0">
+                <a:solidFill>
+                  <a:srgbClr val="2C3E50"/>
+                </a:solidFill>
+                <a:latin typeface="Courier New"/>
+              </a:defRPr>
+            </a:pPr>
+            <a:r>
+              <a:t>       │          PATH_CERT "Certified ✓"        │</a:t>
+            </a:r>
+          </a:p>
+          <a:p>
+            <a:pPr algn="l">
+              <a:defRPr sz="900" b="0">
+                <a:solidFill>
+                  <a:srgbClr val="2C3E50"/>
+                </a:solidFill>
+                <a:latin typeface="Courier New"/>
+              </a:defRPr>
+            </a:pPr>
+            <a:r>
+              <a:t>       │&lt;────────────────────────────────────────┤</a:t>
+            </a:r>
+          </a:p>
+          <a:p>
+            <a:pPr algn="l">
+              <a:defRPr sz="900" b="0">
+                <a:solidFill>
+                  <a:srgbClr val="2C3E50"/>
+                </a:solidFill>
+                <a:latin typeface="Courier New"/>
+              </a:defRPr>
+            </a:pPr>
+            <a:r>
+              <a:t>       │                                         │</a:t>
+            </a:r>
+          </a:p>
+          <a:p>
+            <a:pPr algn="l">
+              <a:defRPr sz="900" b="0">
+                <a:solidFill>
+                  <a:srgbClr val="2C3E50"/>
+                </a:solidFill>
+                <a:latin typeface="Courier New"/>
+              </a:defRPr>
+            </a:pPr>
+            <a:r>
+              <a:t>       │           ACK "Got it"                  │</a:t>
+            </a:r>
+          </a:p>
+          <a:p>
+            <a:pPr algn="l">
+              <a:defRPr sz="900" b="0">
+                <a:solidFill>
+                  <a:srgbClr val="2C3E50"/>
+                </a:solidFill>
+                <a:latin typeface="Courier New"/>
+              </a:defRPr>
+            </a:pPr>
+            <a:r>
+              <a:t>       ├────────────────────────────────────────&gt;│</a:t>
+            </a:r>
+          </a:p>
+          <a:p>
+            <a:pPr algn="l">
+              <a:defRPr sz="900" b="0">
+                <a:solidFill>
+                  <a:srgbClr val="2C3E50"/>
+                </a:solidFill>
+                <a:latin typeface="Courier New"/>
+              </a:defRPr>
+            </a:pPr>
+            <a:r>
+              <a:t>       │                                         │</a:t>
+            </a:r>
+          </a:p>
+          <a:p>
+            <a:pPr algn="l">
+              <a:defRPr sz="900" b="0">
+                <a:solidFill>
+                  <a:srgbClr val="2C3E50"/>
+                </a:solidFill>
+                <a:latin typeface="Courier New"/>
+              </a:defRPr>
+            </a:pPr>
+            <a:r>
+              <a:t>       ●  DONE (3 messages)                      ●</a:t>
             </a:r>
           </a:p>
         </p:txBody>
@@ -4176,8 +4462,8 @@
         </p:nvSpPr>
         <p:spPr>
           <a:xfrm>
-            <a:off x="5943600" y="1097280"/>
-            <a:ext cx="1828800" cy="274320"/>
+            <a:off x="457200" y="4754880"/>
+            <a:ext cx="2743200" cy="274320"/>
           </a:xfrm>
           <a:prstGeom prst="rect">
             <a:avLst/>
@@ -4190,16 +4476,16 @@
           </a:bodyPr>
           <a:lstStyle/>
           <a:p>
-            <a:pPr algn="ctr">
+            <a:pPr algn="l">
               <a:defRPr sz="1400" b="1">
                 <a:solidFill>
-                  <a:srgbClr val="27AE60"/>
-                </a:solidFill>
-                <a:latin typeface="Calibri"/>
-              </a:defRPr>
-            </a:pPr>
-            <a:r>
-              <a:t>AGENT B</a:t>
+                  <a:srgbClr val="E74C3C"/>
+                </a:solidFill>
+                <a:latin typeface="Calibri"/>
+              </a:defRPr>
+            </a:pPr>
+            <a:r>
+              <a:t>With Conflicts:</a:t>
             </a:r>
           </a:p>
         </p:txBody>
@@ -4212,8 +4498,8 @@
         </p:nvSpPr>
         <p:spPr>
           <a:xfrm>
-            <a:off x="5943600" y="1371600"/>
-            <a:ext cx="1828800" cy="274320"/>
+            <a:off x="731520" y="5120640"/>
+            <a:ext cx="7680960" cy="1097280"/>
           </a:xfrm>
           <a:prstGeom prst="rect">
             <a:avLst/>
@@ -4226,159 +4512,29 @@
           </a:bodyPr>
           <a:lstStyle/>
           <a:p>
-            <a:pPr algn="ctr">
-              <a:defRPr sz="1100" b="0">
-                <a:solidFill>
-                  <a:srgbClr val="2C3E50"/>
-                </a:solidFill>
-                <a:latin typeface="Calibri"/>
-              </a:defRPr>
-            </a:pPr>
-            <a:r>
-              <a:t>(Responder)</a:t>
-            </a:r>
-          </a:p>
-        </p:txBody>
-      </p:sp>
-      <p:cxnSp>
-        <p:nvCxnSpPr>
-          <p:cNvPr id="7" name="Connector 6"/>
-          <p:cNvCxnSpPr/>
-          <p:nvPr/>
-        </p:nvCxnSpPr>
-        <p:spPr>
-          <a:xfrm>
-            <a:off x="2286000" y="2011680"/>
-            <a:ext cx="4572000" cy="182880"/>
-          </a:xfrm>
-          <a:prstGeom prst="line">
-            <a:avLst/>
-          </a:prstGeom>
-          <a:ln w="31750">
-            <a:solidFill>
-              <a:srgbClr val="2980B9"/>
-            </a:solidFill>
-          </a:ln>
-        </p:spPr>
-        <p:style>
-          <a:lnRef idx="2">
-            <a:schemeClr val="accent1"/>
-          </a:lnRef>
-          <a:fillRef idx="0">
-            <a:schemeClr val="accent1"/>
-          </a:fillRef>
-          <a:effectRef idx="1">
-            <a:schemeClr val="accent1"/>
-          </a:effectRef>
-          <a:fontRef idx="minor">
-            <a:schemeClr val="tx1"/>
-          </a:fontRef>
-        </p:style>
-      </p:cxnSp>
-      <p:sp>
-        <p:nvSpPr>
-          <p:cNvPr id="8" name="TextBox 7"/>
-          <p:cNvSpPr txBox="1"/>
-          <p:nvPr/>
-        </p:nvSpPr>
-        <p:spPr>
-          <a:xfrm>
-            <a:off x="3200400" y="1828800"/>
-            <a:ext cx="2743200" cy="228600"/>
-          </a:xfrm>
-          <a:prstGeom prst="rect">
-            <a:avLst/>
-          </a:prstGeom>
-          <a:noFill/>
-        </p:spPr>
-        <p:txBody>
-          <a:bodyPr wrap="square">
-            <a:spAutoFit/>
-          </a:bodyPr>
-          <a:lstStyle/>
-          <a:p>
-            <a:pPr algn="ctr">
-              <a:defRPr sz="1100" b="1">
-                <a:solidFill>
-                  <a:srgbClr val="2980B9"/>
-                </a:solidFill>
-                <a:latin typeface="Calibri"/>
-              </a:defRPr>
-            </a:pPr>
-            <a:r>
-              <a:t>PATH_PROPOSE</a:t>
-            </a:r>
-          </a:p>
-        </p:txBody>
-      </p:sp>
-      <p:sp>
-        <p:nvSpPr>
-          <p:cNvPr id="9" name="TextBox 8"/>
-          <p:cNvSpPr txBox="1"/>
-          <p:nvPr/>
-        </p:nvSpPr>
-        <p:spPr>
-          <a:xfrm>
-            <a:off x="3200400" y="2057400"/>
-            <a:ext cx="2743200" cy="228600"/>
-          </a:xfrm>
-          <a:prstGeom prst="rect">
-            <a:avLst/>
-          </a:prstGeom>
-          <a:noFill/>
-        </p:spPr>
-        <p:txBody>
-          <a:bodyPr wrap="square">
-            <a:spAutoFit/>
-          </a:bodyPr>
-          <a:lstStyle/>
-          <a:p>
-            <a:pPr algn="ctr">
+            <a:pPr algn="l">
               <a:defRPr sz="900" b="0">
                 <a:solidFill>
                   <a:srgbClr val="2C3E50"/>
                 </a:solidFill>
-                <a:latin typeface="Calibri"/>
-              </a:defRPr>
-            </a:pPr>
-            <a:r>
-              <a:t>"Try this route: ↓↓↓→→→"</a:t>
-            </a:r>
-          </a:p>
-        </p:txBody>
-      </p:sp>
-      <p:sp>
-        <p:nvSpPr>
-          <p:cNvPr id="10" name="TextBox 9"/>
-          <p:cNvSpPr txBox="1"/>
-          <p:nvPr/>
-        </p:nvSpPr>
-        <p:spPr>
-          <a:xfrm>
-            <a:off x="7132320" y="2286000"/>
-            <a:ext cx="1371600" cy="365760"/>
-          </a:xfrm>
-          <a:prstGeom prst="rect">
-            <a:avLst/>
-          </a:prstGeom>
-          <a:noFill/>
-        </p:spPr>
-        <p:txBody>
-          <a:bodyPr wrap="square">
-            <a:spAutoFit/>
-          </a:bodyPr>
-          <a:lstStyle/>
+                <a:latin typeface="Courier New"/>
+              </a:defRPr>
+            </a:pPr>
+            <a:r>
+              <a:t>CUT_PROPOSE "Barrier: cells X,Y,Z"  →  NACK "Can't verify Y"</a:t>
+            </a:r>
+          </a:p>
           <a:p>
             <a:pPr algn="l">
               <a:defRPr sz="900" b="0">
                 <a:solidFill>
                   <a:srgbClr val="2C3E50"/>
                 </a:solidFill>
-                <a:latin typeface="Calibri"/>
-              </a:defRPr>
-            </a:pPr>
-            <a:r>
-              <a:t>Check against</a:t>
+                <a:latin typeface="Courier New"/>
+              </a:defRPr>
+            </a:pPr>
+            <a:r>
+              <a:t>PROBE "Is Y blocked?"  →  PROBE_REPLY "Yes"</a:t>
             </a:r>
           </a:p>
           <a:p>
@@ -4387,411 +4543,24 @@
                 <a:solidFill>
                   <a:srgbClr val="2C3E50"/>
                 </a:solidFill>
-                <a:latin typeface="Calibri"/>
-              </a:defRPr>
-            </a:pPr>
-            <a:r>
-              <a:t>private map</a:t>
-            </a:r>
-          </a:p>
-        </p:txBody>
-      </p:sp>
-      <p:cxnSp>
-        <p:nvCxnSpPr>
-          <p:cNvPr id="11" name="Connector 10"/>
-          <p:cNvCxnSpPr/>
-          <p:nvPr/>
-        </p:nvCxnSpPr>
-        <p:spPr>
-          <a:xfrm flipH="1">
-            <a:off x="2286000" y="2743200"/>
-            <a:ext cx="4572000" cy="182880"/>
-          </a:xfrm>
-          <a:prstGeom prst="line">
-            <a:avLst/>
-          </a:prstGeom>
-          <a:ln w="31750">
-            <a:solidFill>
-              <a:srgbClr val="27AE60"/>
-            </a:solidFill>
-          </a:ln>
-        </p:spPr>
-        <p:style>
-          <a:lnRef idx="2">
-            <a:schemeClr val="accent1"/>
-          </a:lnRef>
-          <a:fillRef idx="0">
-            <a:schemeClr val="accent1"/>
-          </a:fillRef>
-          <a:effectRef idx="1">
-            <a:schemeClr val="accent1"/>
-          </a:effectRef>
-          <a:fontRef idx="minor">
-            <a:schemeClr val="tx1"/>
-          </a:fontRef>
-        </p:style>
-      </p:cxnSp>
-      <p:sp>
-        <p:nvSpPr>
-          <p:cNvPr id="12" name="TextBox 11"/>
-          <p:cNvSpPr txBox="1"/>
-          <p:nvPr/>
-        </p:nvSpPr>
-        <p:spPr>
-          <a:xfrm>
-            <a:off x="3474720" y="2560320"/>
-            <a:ext cx="2743200" cy="228600"/>
-          </a:xfrm>
-          <a:prstGeom prst="rect">
-            <a:avLst/>
-          </a:prstGeom>
-          <a:noFill/>
-        </p:spPr>
-        <p:txBody>
-          <a:bodyPr wrap="square">
-            <a:spAutoFit/>
-          </a:bodyPr>
-          <a:lstStyle/>
-          <a:p>
-            <a:pPr algn="ctr">
-              <a:defRPr sz="1100" b="1">
-                <a:solidFill>
-                  <a:srgbClr val="27AE60"/>
-                </a:solidFill>
-                <a:latin typeface="Calibri"/>
-              </a:defRPr>
-            </a:pPr>
-            <a:r>
-              <a:t>PATH_CERT</a:t>
-            </a:r>
-          </a:p>
-        </p:txBody>
-      </p:sp>
-      <p:sp>
-        <p:nvSpPr>
-          <p:cNvPr id="13" name="TextBox 12"/>
-          <p:cNvSpPr txBox="1"/>
-          <p:nvPr/>
-        </p:nvSpPr>
-        <p:spPr>
-          <a:xfrm>
-            <a:off x="3474720" y="2788920"/>
-            <a:ext cx="2743200" cy="228600"/>
-          </a:xfrm>
-          <a:prstGeom prst="rect">
-            <a:avLst/>
-          </a:prstGeom>
-          <a:noFill/>
-        </p:spPr>
-        <p:txBody>
-          <a:bodyPr wrap="square">
-            <a:spAutoFit/>
-          </a:bodyPr>
-          <a:lstStyle/>
-          <a:p>
-            <a:pPr algn="ctr">
+                <a:latin typeface="Courier New"/>
+              </a:defRPr>
+            </a:pPr>
+            <a:r>
+              <a:t>CUT_PROPOSE (revised)  →  CUT_CERT ✓</a:t>
+            </a:r>
+          </a:p>
+          <a:p>
+            <a:pPr algn="l">
               <a:defRPr sz="900" b="0">
                 <a:solidFill>
                   <a:srgbClr val="2C3E50"/>
                 </a:solidFill>
-                <a:latin typeface="Calibri"/>
-              </a:defRPr>
-            </a:pPr>
-            <a:r>
-              <a:t>"Certified ✓"</a:t>
-            </a:r>
-          </a:p>
-        </p:txBody>
-      </p:sp>
-      <p:cxnSp>
-        <p:nvCxnSpPr>
-          <p:cNvPr id="14" name="Connector 13"/>
-          <p:cNvCxnSpPr/>
-          <p:nvPr/>
-        </p:nvCxnSpPr>
-        <p:spPr>
-          <a:xfrm>
-            <a:off x="2286000" y="3291840"/>
-            <a:ext cx="4572000" cy="182880"/>
-          </a:xfrm>
-          <a:prstGeom prst="line">
-            <a:avLst/>
-          </a:prstGeom>
-          <a:ln w="31750">
-            <a:solidFill>
-              <a:srgbClr val="2980B9"/>
-            </a:solidFill>
-          </a:ln>
-        </p:spPr>
-        <p:style>
-          <a:lnRef idx="2">
-            <a:schemeClr val="accent1"/>
-          </a:lnRef>
-          <a:fillRef idx="0">
-            <a:schemeClr val="accent1"/>
-          </a:fillRef>
-          <a:effectRef idx="1">
-            <a:schemeClr val="accent1"/>
-          </a:effectRef>
-          <a:fontRef idx="minor">
-            <a:schemeClr val="tx1"/>
-          </a:fontRef>
-        </p:style>
-      </p:cxnSp>
-      <p:sp>
-        <p:nvSpPr>
-          <p:cNvPr id="15" name="TextBox 14"/>
-          <p:cNvSpPr txBox="1"/>
-          <p:nvPr/>
-        </p:nvSpPr>
-        <p:spPr>
-          <a:xfrm>
-            <a:off x="3840480" y="3200400"/>
-            <a:ext cx="1828800" cy="228600"/>
-          </a:xfrm>
-          <a:prstGeom prst="rect">
-            <a:avLst/>
-          </a:prstGeom>
-          <a:noFill/>
-        </p:spPr>
-        <p:txBody>
-          <a:bodyPr wrap="square">
-            <a:spAutoFit/>
-          </a:bodyPr>
-          <a:lstStyle/>
-          <a:p>
-            <a:pPr algn="ctr">
-              <a:defRPr sz="1000" b="0">
-                <a:solidFill>
-                  <a:srgbClr val="2C3E50"/>
-                </a:solidFill>
-                <a:latin typeface="Calibri"/>
-              </a:defRPr>
-            </a:pPr>
-            <a:r>
-              <a:t>ACK "Got it"</a:t>
-            </a:r>
-          </a:p>
-        </p:txBody>
-      </p:sp>
-      <p:sp>
-        <p:nvSpPr>
-          <p:cNvPr id="16" name="TextBox 15"/>
-          <p:cNvSpPr txBox="1"/>
-          <p:nvPr/>
-        </p:nvSpPr>
-        <p:spPr>
-          <a:xfrm>
-            <a:off x="1097280" y="3840480"/>
-            <a:ext cx="2743200" cy="274320"/>
-          </a:xfrm>
-          <a:prstGeom prst="rect">
-            <a:avLst/>
-          </a:prstGeom>
-          <a:noFill/>
-        </p:spPr>
-        <p:txBody>
-          <a:bodyPr wrap="square">
-            <a:spAutoFit/>
-          </a:bodyPr>
-          <a:lstStyle/>
-          <a:p>
-            <a:pPr algn="l">
-              <a:defRPr sz="1200" b="1">
-                <a:solidFill>
-                  <a:srgbClr val="2C3E50"/>
-                </a:solidFill>
-                <a:latin typeface="Calibri"/>
-              </a:defRPr>
-            </a:pPr>
-            <a:r>
-              <a:t>● DONE (3 messages)</a:t>
-            </a:r>
-          </a:p>
-        </p:txBody>
-      </p:sp>
-      <p:sp>
-        <p:nvSpPr>
-          <p:cNvPr id="17" name="TextBox 16"/>
-          <p:cNvSpPr txBox="1"/>
-          <p:nvPr/>
-        </p:nvSpPr>
-        <p:spPr>
-          <a:xfrm>
-            <a:off x="5943600" y="3840480"/>
-            <a:ext cx="914400" cy="274320"/>
-          </a:xfrm>
-          <a:prstGeom prst="rect">
-            <a:avLst/>
-          </a:prstGeom>
-          <a:noFill/>
-        </p:spPr>
-        <p:txBody>
-          <a:bodyPr wrap="square">
-            <a:spAutoFit/>
-          </a:bodyPr>
-          <a:lstStyle/>
-          <a:p>
-            <a:pPr algn="l">
-              <a:defRPr sz="1200" b="1">
-                <a:solidFill>
-                  <a:srgbClr val="27AE60"/>
-                </a:solidFill>
-                <a:latin typeface="Calibri"/>
-              </a:defRPr>
-            </a:pPr>
-            <a:r>
-              <a:t>●</a:t>
-            </a:r>
-          </a:p>
-        </p:txBody>
-      </p:sp>
-      <p:sp>
-        <p:nvSpPr>
-          <p:cNvPr id="18" name="TextBox 17"/>
-          <p:cNvSpPr txBox="1"/>
-          <p:nvPr/>
-        </p:nvSpPr>
-        <p:spPr>
-          <a:xfrm>
-            <a:off x="457200" y="4297680"/>
-            <a:ext cx="1828800" cy="274320"/>
-          </a:xfrm>
-          <a:prstGeom prst="rect">
-            <a:avLst/>
-          </a:prstGeom>
-          <a:noFill/>
-        </p:spPr>
-        <p:txBody>
-          <a:bodyPr wrap="square">
-            <a:spAutoFit/>
-          </a:bodyPr>
-          <a:lstStyle/>
-          <a:p>
-            <a:pPr algn="l">
-              <a:defRPr sz="1200" b="1">
-                <a:solidFill>
-                  <a:srgbClr val="2C3E50"/>
-                </a:solidFill>
-                <a:latin typeface="Calibri"/>
-              </a:defRPr>
-            </a:pPr>
-            <a:r>
-              <a:t>With conflicts:</a:t>
-            </a:r>
-          </a:p>
-        </p:txBody>
-      </p:sp>
-      <p:sp>
-        <p:nvSpPr>
-          <p:cNvPr id="19" name="TextBox 18"/>
-          <p:cNvSpPr txBox="1"/>
-          <p:nvPr/>
-        </p:nvSpPr>
-        <p:spPr>
-          <a:xfrm>
-            <a:off x="731520" y="4572000"/>
-            <a:ext cx="7315200" cy="1371600"/>
-          </a:xfrm>
-          <a:prstGeom prst="rect">
-            <a:avLst/>
-          </a:prstGeom>
-          <a:noFill/>
-        </p:spPr>
-        <p:txBody>
-          <a:bodyPr wrap="square">
-            <a:spAutoFit/>
-          </a:bodyPr>
-          <a:lstStyle/>
-          <a:p>
-            <a:pPr algn="l">
-              <a:defRPr sz="1000" b="0">
-                <a:solidFill>
-                  <a:srgbClr val="2C3E50"/>
-                </a:solidFill>
                 <a:latin typeface="Courier New"/>
               </a:defRPr>
             </a:pPr>
             <a:r>
-              <a:t>│  CUT_PROPOSE "Barrier: cells X,Y,Z"</a:t>
-            </a:r>
-          </a:p>
-          <a:p>
-            <a:pPr algn="l">
-              <a:defRPr sz="1000" b="0">
-                <a:solidFill>
-                  <a:srgbClr val="2C3E50"/>
-                </a:solidFill>
-                <a:latin typeface="Courier New"/>
-              </a:defRPr>
-            </a:pPr>
-            <a:r>
-              <a:t>│  ────────────&gt; NACK "Can't verify Y"</a:t>
-            </a:r>
-          </a:p>
-          <a:p>
-            <a:pPr algn="l">
-              <a:defRPr sz="1000" b="0">
-                <a:solidFill>
-                  <a:srgbClr val="2C3E50"/>
-                </a:solidFill>
-                <a:latin typeface="Courier New"/>
-              </a:defRPr>
-            </a:pPr>
-            <a:r>
-              <a:t>│  PROBE "Is Y blocked?"</a:t>
-            </a:r>
-          </a:p>
-          <a:p>
-            <a:pPr algn="l">
-              <a:defRPr sz="1000" b="0">
-                <a:solidFill>
-                  <a:srgbClr val="2C3E50"/>
-                </a:solidFill>
-                <a:latin typeface="Courier New"/>
-              </a:defRPr>
-            </a:pPr>
-            <a:r>
-              <a:t>│  ────────────&gt; PROBE_REPLY "Yes"</a:t>
-            </a:r>
-          </a:p>
-          <a:p>
-            <a:pPr algn="l">
-              <a:defRPr sz="1000" b="0">
-                <a:solidFill>
-                  <a:srgbClr val="2C3E50"/>
-                </a:solidFill>
-                <a:latin typeface="Courier New"/>
-              </a:defRPr>
-            </a:pPr>
-            <a:r>
-              <a:t>│  CUT_PROPOSE (revised)</a:t>
-            </a:r>
-          </a:p>
-          <a:p>
-            <a:pPr algn="l">
-              <a:defRPr sz="1000" b="0">
-                <a:solidFill>
-                  <a:srgbClr val="2C3E50"/>
-                </a:solidFill>
-                <a:latin typeface="Courier New"/>
-              </a:defRPr>
-            </a:pPr>
-            <a:r>
-              <a:t>│  ────────────&gt; CUT_CERT ✓</a:t>
-            </a:r>
-          </a:p>
-          <a:p>
-            <a:pPr algn="l">
-              <a:defRPr sz="1000" b="0">
-                <a:solidFill>
-                  <a:srgbClr val="2C3E50"/>
-                </a:solidFill>
-                <a:latin typeface="Courier New"/>
-              </a:defRPr>
-            </a:pPr>
-            <a:r>
-              <a:t>●  DONE (5-6 messages)</a:t>
+              <a:t>DONE (5-6 messages)</a:t>
             </a:r>
           </a:p>
         </p:txBody>
@@ -5040,599 +4809,23 @@
       </p:sp>
       <p:sp>
         <p:nvSpPr>
-          <p:cNvPr id="8" name="TextBox 7"/>
-          <p:cNvSpPr txBox="1"/>
-          <p:nvPr/>
-        </p:nvSpPr>
-        <p:spPr>
-          <a:xfrm>
-            <a:off x="640080" y="2194560"/>
-            <a:ext cx="2103120" cy="228600"/>
-          </a:xfrm>
-          <a:prstGeom prst="rect">
-            <a:avLst/>
-          </a:prstGeom>
-          <a:noFill/>
-        </p:spPr>
-        <p:txBody>
-          <a:bodyPr wrap="square">
-            <a:spAutoFit/>
-          </a:bodyPr>
-          <a:lstStyle/>
-          <a:p>
-            <a:pPr algn="l">
-              <a:defRPr sz="1000" b="0">
-                <a:solidFill>
-                  <a:srgbClr val="2C3E50"/>
-                </a:solidFill>
-                <a:latin typeface="Calibri"/>
-              </a:defRPr>
-            </a:pPr>
-            <a:r>
-              <a:t>(2,1) ← A sees #</a:t>
-            </a:r>
-          </a:p>
-        </p:txBody>
-      </p:sp>
-      <p:sp>
-        <p:nvSpPr>
-          <p:cNvPr id="9" name="TextBox 8"/>
-          <p:cNvSpPr txBox="1"/>
-          <p:nvPr/>
-        </p:nvSpPr>
-        <p:spPr>
-          <a:xfrm>
-            <a:off x="2926080" y="2194560"/>
-            <a:ext cx="2286000" cy="228600"/>
-          </a:xfrm>
-          <a:prstGeom prst="rect">
-            <a:avLst/>
-          </a:prstGeom>
-          <a:noFill/>
-        </p:spPr>
-        <p:txBody>
-          <a:bodyPr wrap="square">
-            <a:spAutoFit/>
-          </a:bodyPr>
-          <a:lstStyle/>
-          <a:p>
-            <a:pPr algn="l">
-              <a:defRPr sz="1000" b="0">
-                <a:solidFill>
-                  <a:srgbClr val="2C3E50"/>
-                </a:solidFill>
-                <a:latin typeface="Calibri"/>
-              </a:defRPr>
-            </a:pPr>
-            <a:r>
-              <a:t>bit=0 "A vouches"</a:t>
-            </a:r>
-          </a:p>
-        </p:txBody>
-      </p:sp>
-      <p:sp>
-        <p:nvSpPr>
-          <p:cNvPr id="10" name="TextBox 9"/>
-          <p:cNvSpPr txBox="1"/>
-          <p:nvPr/>
-        </p:nvSpPr>
-        <p:spPr>
-          <a:xfrm>
-            <a:off x="5669280" y="2194560"/>
-            <a:ext cx="2286000" cy="228600"/>
-          </a:xfrm>
-          <a:prstGeom prst="rect">
-            <a:avLst/>
-          </a:prstGeom>
-          <a:noFill/>
-        </p:spPr>
-        <p:txBody>
-          <a:bodyPr wrap="square">
-            <a:spAutoFit/>
-          </a:bodyPr>
-          <a:lstStyle/>
-          <a:p>
-            <a:pPr algn="l">
-              <a:defRPr sz="1000" b="0">
-                <a:solidFill>
-                  <a:srgbClr val="2C3E50"/>
-                </a:solidFill>
-                <a:latin typeface="Calibri"/>
-              </a:defRPr>
-            </a:pPr>
-            <a:r>
-              <a:t>Accept if:</a:t>
-            </a:r>
-          </a:p>
-        </p:txBody>
-      </p:sp>
-      <p:sp>
-        <p:nvSpPr>
-          <p:cNvPr id="11" name="TextBox 10"/>
-          <p:cNvSpPr txBox="1"/>
-          <p:nvPr/>
-        </p:nvSpPr>
-        <p:spPr>
-          <a:xfrm>
-            <a:off x="640080" y="2468880"/>
-            <a:ext cx="2103120" cy="228600"/>
-          </a:xfrm>
-          <a:prstGeom prst="rect">
-            <a:avLst/>
-          </a:prstGeom>
-          <a:noFill/>
-        </p:spPr>
-        <p:txBody>
-          <a:bodyPr wrap="square">
-            <a:spAutoFit/>
-          </a:bodyPr>
-          <a:lstStyle/>
-          <a:p>
-            <a:pPr algn="l">
-              <a:defRPr sz="1000" b="0">
-                <a:solidFill>
-                  <a:srgbClr val="2C3E50"/>
-                </a:solidFill>
-                <a:latin typeface="Calibri"/>
-              </a:defRPr>
-            </a:pPr>
-            <a:r>
-              <a:t>(2,2) ← A sees #</a:t>
-            </a:r>
-          </a:p>
-        </p:txBody>
-      </p:sp>
-      <p:sp>
-        <p:nvSpPr>
-          <p:cNvPr id="12" name="TextBox 11"/>
-          <p:cNvSpPr txBox="1"/>
-          <p:nvPr/>
-        </p:nvSpPr>
-        <p:spPr>
-          <a:xfrm>
-            <a:off x="2926080" y="2468880"/>
-            <a:ext cx="2286000" cy="228600"/>
-          </a:xfrm>
-          <a:prstGeom prst="rect">
-            <a:avLst/>
-          </a:prstGeom>
-          <a:noFill/>
-        </p:spPr>
-        <p:txBody>
-          <a:bodyPr wrap="square">
-            <a:spAutoFit/>
-          </a:bodyPr>
-          <a:lstStyle/>
-          <a:p>
-            <a:pPr algn="l">
-              <a:defRPr sz="1000" b="0">
-                <a:solidFill>
-                  <a:srgbClr val="2C3E50"/>
-                </a:solidFill>
-                <a:latin typeface="Calibri"/>
-              </a:defRPr>
-            </a:pPr>
-            <a:r>
-              <a:t>bit=0 "A vouches"</a:t>
-            </a:r>
-          </a:p>
-        </p:txBody>
-      </p:sp>
-      <p:sp>
-        <p:nvSpPr>
-          <p:cNvPr id="13" name="TextBox 12"/>
-          <p:cNvSpPr txBox="1"/>
-          <p:nvPr/>
-        </p:nvSpPr>
-        <p:spPr>
-          <a:xfrm>
-            <a:off x="5669280" y="2468880"/>
-            <a:ext cx="2286000" cy="228600"/>
-          </a:xfrm>
-          <a:prstGeom prst="rect">
-            <a:avLst/>
-          </a:prstGeom>
-          <a:noFill/>
-        </p:spPr>
-        <p:txBody>
-          <a:bodyPr wrap="square">
-            <a:spAutoFit/>
-          </a:bodyPr>
-          <a:lstStyle/>
-          <a:p>
-            <a:pPr algn="l">
-              <a:defRPr sz="1000" b="0">
-                <a:solidFill>
-                  <a:srgbClr val="2C3E50"/>
-                </a:solidFill>
-                <a:latin typeface="Calibri"/>
-              </a:defRPr>
-            </a:pPr>
-            <a:r>
-              <a:t>- B sees #</a:t>
-            </a:r>
-          </a:p>
-        </p:txBody>
-      </p:sp>
-      <p:sp>
-        <p:nvSpPr>
-          <p:cNvPr id="14" name="TextBox 13"/>
-          <p:cNvSpPr txBox="1"/>
-          <p:nvPr/>
-        </p:nvSpPr>
-        <p:spPr>
-          <a:xfrm>
-            <a:off x="640080" y="2743200"/>
-            <a:ext cx="2103120" cy="228600"/>
-          </a:xfrm>
-          <a:prstGeom prst="rect">
-            <a:avLst/>
-          </a:prstGeom>
-          <a:noFill/>
-        </p:spPr>
-        <p:txBody>
-          <a:bodyPr wrap="square">
-            <a:spAutoFit/>
-          </a:bodyPr>
-          <a:lstStyle/>
-          <a:p>
-            <a:pPr algn="l">
-              <a:defRPr sz="1000" b="0">
-                <a:solidFill>
-                  <a:srgbClr val="2C3E50"/>
-                </a:solidFill>
-                <a:latin typeface="Calibri"/>
-              </a:defRPr>
-            </a:pPr>
-            <a:r>
-              <a:t>(2,3) ← A sees #</a:t>
-            </a:r>
-          </a:p>
-        </p:txBody>
-      </p:sp>
-      <p:sp>
-        <p:nvSpPr>
-          <p:cNvPr id="15" name="TextBox 14"/>
-          <p:cNvSpPr txBox="1"/>
-          <p:nvPr/>
-        </p:nvSpPr>
-        <p:spPr>
-          <a:xfrm>
-            <a:off x="2926080" y="2743200"/>
-            <a:ext cx="2286000" cy="228600"/>
-          </a:xfrm>
-          <a:prstGeom prst="rect">
-            <a:avLst/>
-          </a:prstGeom>
-          <a:noFill/>
-        </p:spPr>
-        <p:txBody>
-          <a:bodyPr wrap="square">
-            <a:spAutoFit/>
-          </a:bodyPr>
-          <a:lstStyle/>
-          <a:p>
-            <a:pPr algn="l">
-              <a:defRPr sz="1000" b="0">
-                <a:solidFill>
-                  <a:srgbClr val="27AE60"/>
-                </a:solidFill>
-                <a:latin typeface="Calibri"/>
-              </a:defRPr>
-            </a:pPr>
-            <a:r>
-              <a:t>bit=1 "B vouches"</a:t>
-            </a:r>
-          </a:p>
-        </p:txBody>
-      </p:sp>
-      <p:sp>
-        <p:nvSpPr>
-          <p:cNvPr id="16" name="TextBox 15"/>
-          <p:cNvSpPr txBox="1"/>
-          <p:nvPr/>
-        </p:nvSpPr>
-        <p:spPr>
-          <a:xfrm>
-            <a:off x="5669280" y="2743200"/>
-            <a:ext cx="2286000" cy="228600"/>
-          </a:xfrm>
-          <a:prstGeom prst="rect">
-            <a:avLst/>
-          </a:prstGeom>
-          <a:noFill/>
-        </p:spPr>
-        <p:txBody>
-          <a:bodyPr wrap="square">
-            <a:spAutoFit/>
-          </a:bodyPr>
-          <a:lstStyle/>
-          <a:p>
-            <a:pPr algn="l">
-              <a:defRPr sz="1000" b="1">
-                <a:solidFill>
-                  <a:srgbClr val="2C3E50"/>
-                </a:solidFill>
-                <a:latin typeface="Calibri"/>
-              </a:defRPr>
-            </a:pPr>
-            <a:r>
-              <a:t>OR</a:t>
-            </a:r>
-          </a:p>
-        </p:txBody>
-      </p:sp>
-      <p:sp>
-        <p:nvSpPr>
-          <p:cNvPr id="17" name="TextBox 16"/>
-          <p:cNvSpPr txBox="1"/>
-          <p:nvPr/>
-        </p:nvSpPr>
-        <p:spPr>
-          <a:xfrm>
-            <a:off x="640080" y="3017520"/>
-            <a:ext cx="2103120" cy="228600"/>
-          </a:xfrm>
-          <a:prstGeom prst="rect">
-            <a:avLst/>
-          </a:prstGeom>
-          <a:noFill/>
-        </p:spPr>
-        <p:txBody>
-          <a:bodyPr wrap="square">
-            <a:spAutoFit/>
-          </a:bodyPr>
-          <a:lstStyle/>
-          <a:p>
-            <a:pPr algn="l">
-              <a:defRPr sz="1000" b="0">
-                <a:solidFill>
-                  <a:srgbClr val="2C3E50"/>
-                </a:solidFill>
-                <a:latin typeface="Calibri"/>
-              </a:defRPr>
-            </a:pPr>
-            <a:r>
-              <a:t>(2,4) ← A sees .</a:t>
-            </a:r>
-          </a:p>
-        </p:txBody>
-      </p:sp>
-      <p:sp>
-        <p:nvSpPr>
-          <p:cNvPr id="18" name="TextBox 17"/>
-          <p:cNvSpPr txBox="1"/>
-          <p:nvPr/>
-        </p:nvSpPr>
-        <p:spPr>
-          <a:xfrm>
-            <a:off x="2926080" y="3017520"/>
-            <a:ext cx="2286000" cy="228600"/>
-          </a:xfrm>
-          <a:prstGeom prst="rect">
-            <a:avLst/>
-          </a:prstGeom>
-          <a:noFill/>
-        </p:spPr>
-        <p:txBody>
-          <a:bodyPr wrap="square">
-            <a:spAutoFit/>
-          </a:bodyPr>
-          <a:lstStyle/>
-          <a:p>
-            <a:pPr algn="l">
-              <a:defRPr sz="1000" b="0">
-                <a:solidFill>
-                  <a:srgbClr val="27AE60"/>
-                </a:solidFill>
-                <a:latin typeface="Calibri"/>
-              </a:defRPr>
-            </a:pPr>
-            <a:r>
-              <a:t>bit=1 "B vouches"</a:t>
-            </a:r>
-          </a:p>
-        </p:txBody>
-      </p:sp>
-      <p:sp>
-        <p:nvSpPr>
-          <p:cNvPr id="19" name="TextBox 18"/>
-          <p:cNvSpPr txBox="1"/>
-          <p:nvPr/>
-        </p:nvSpPr>
-        <p:spPr>
-          <a:xfrm>
-            <a:off x="5669280" y="3017520"/>
-            <a:ext cx="2286000" cy="228600"/>
-          </a:xfrm>
-          <a:prstGeom prst="rect">
-            <a:avLst/>
-          </a:prstGeom>
-          <a:noFill/>
-        </p:spPr>
-        <p:txBody>
-          <a:bodyPr wrap="square">
-            <a:spAutoFit/>
-          </a:bodyPr>
-          <a:lstStyle/>
-          <a:p>
-            <a:pPr algn="l">
-              <a:defRPr sz="1000" b="0">
-                <a:solidFill>
-                  <a:srgbClr val="2C3E50"/>
-                </a:solidFill>
-                <a:latin typeface="Calibri"/>
-              </a:defRPr>
-            </a:pPr>
-            <a:r>
-              <a:t>- bit=0</a:t>
-            </a:r>
-          </a:p>
-        </p:txBody>
-      </p:sp>
-      <p:sp>
-        <p:nvSpPr>
-          <p:cNvPr id="20" name="TextBox 19"/>
-          <p:cNvSpPr txBox="1"/>
-          <p:nvPr/>
-        </p:nvSpPr>
-        <p:spPr>
-          <a:xfrm>
-            <a:off x="3200400" y="3383280"/>
-            <a:ext cx="914400" cy="274320"/>
-          </a:xfrm>
-          <a:prstGeom prst="rect">
-            <a:avLst/>
-          </a:prstGeom>
-          <a:noFill/>
-        </p:spPr>
-        <p:txBody>
-          <a:bodyPr wrap="square">
-            <a:spAutoFit/>
-          </a:bodyPr>
-          <a:lstStyle/>
-          <a:p>
-            <a:pPr algn="ctr">
-              <a:defRPr sz="2000" b="0">
-                <a:solidFill>
-                  <a:srgbClr val="2C3E50"/>
-                </a:solidFill>
-                <a:latin typeface="Calibri"/>
-              </a:defRPr>
-            </a:pPr>
-            <a:r>
-              <a:t>↓</a:t>
-            </a:r>
-          </a:p>
-        </p:txBody>
-      </p:sp>
-      <p:sp>
-        <p:nvSpPr>
-          <p:cNvPr id="21" name="TextBox 20"/>
-          <p:cNvSpPr txBox="1"/>
-          <p:nvPr/>
-        </p:nvSpPr>
-        <p:spPr>
-          <a:xfrm>
-            <a:off x="1371600" y="3749039"/>
-            <a:ext cx="4572000" cy="228600"/>
-          </a:xfrm>
-          <a:prstGeom prst="rect">
-            <a:avLst/>
-          </a:prstGeom>
-          <a:noFill/>
-        </p:spPr>
-        <p:txBody>
-          <a:bodyPr wrap="square">
-            <a:spAutoFit/>
-          </a:bodyPr>
-          <a:lstStyle/>
-          <a:p>
-            <a:pPr algn="l">
-              <a:defRPr sz="1100" b="0">
-                <a:solidFill>
-                  <a:srgbClr val="27AE60"/>
-                </a:solidFill>
-                <a:latin typeface="Calibri"/>
-              </a:defRPr>
-            </a:pPr>
-            <a:r>
-              <a:t>B checks (2,3): B sees #  ✓ Accept</a:t>
-            </a:r>
-          </a:p>
-        </p:txBody>
-      </p:sp>
-      <p:sp>
-        <p:nvSpPr>
-          <p:cNvPr id="22" name="TextBox 21"/>
-          <p:cNvSpPr txBox="1"/>
-          <p:nvPr/>
-        </p:nvSpPr>
-        <p:spPr>
-          <a:xfrm>
-            <a:off x="1371600" y="4023360"/>
-            <a:ext cx="4572000" cy="228600"/>
-          </a:xfrm>
-          <a:prstGeom prst="rect">
-            <a:avLst/>
-          </a:prstGeom>
-          <a:noFill/>
-        </p:spPr>
-        <p:txBody>
-          <a:bodyPr wrap="square">
-            <a:spAutoFit/>
-          </a:bodyPr>
-          <a:lstStyle/>
-          <a:p>
-            <a:pPr algn="l">
-              <a:defRPr sz="1100" b="0">
-                <a:solidFill>
-                  <a:srgbClr val="27AE60"/>
-                </a:solidFill>
-                <a:latin typeface="Calibri"/>
-              </a:defRPr>
-            </a:pPr>
-            <a:r>
-              <a:t>B checks (2,4): B sees #  ✓ Accept</a:t>
-            </a:r>
-          </a:p>
-        </p:txBody>
-      </p:sp>
-      <p:sp>
-        <p:nvSpPr>
-          <p:cNvPr id="23" name="TextBox 22"/>
-          <p:cNvSpPr txBox="1"/>
-          <p:nvPr/>
-        </p:nvSpPr>
-        <p:spPr>
-          <a:xfrm>
-            <a:off x="1371600" y="4389120"/>
-            <a:ext cx="5486400" cy="274320"/>
-          </a:xfrm>
-          <a:prstGeom prst="rect">
-            <a:avLst/>
-          </a:prstGeom>
-          <a:noFill/>
-        </p:spPr>
-        <p:txBody>
-          <a:bodyPr wrap="square">
-            <a:spAutoFit/>
-          </a:bodyPr>
-          <a:lstStyle/>
-          <a:p>
-            <a:pPr algn="l">
-              <a:defRPr sz="1100" b="0">
-                <a:solidFill>
-                  <a:srgbClr val="E74C3C"/>
-                </a:solidFill>
-                <a:latin typeface="Calibri"/>
-              </a:defRPr>
-            </a:pPr>
-            <a:r>
-              <a:t>If witness=1 but B sees free → NACK → PROBE</a:t>
-            </a:r>
-          </a:p>
-        </p:txBody>
-      </p:sp>
-      <p:sp>
-        <p:nvSpPr>
-          <p:cNvPr id="24" name="Rectangle 23"/>
+          <p:cNvPr id="8" name="Rectangle 7"/>
           <p:cNvSpPr/>
           <p:nvPr/>
         </p:nvSpPr>
         <p:spPr>
           <a:xfrm>
-            <a:off x="457200" y="5029200"/>
-            <a:ext cx="8229600" cy="1188720"/>
-          </a:xfrm>
-          <a:prstGeom prst="rect">
-            <a:avLst/>
-          </a:prstGeom>
-          <a:noFill/>
-          <a:ln w="25400">
-            <a:solidFill>
-              <a:srgbClr val="F39C12"/>
-            </a:solidFill>
+            <a:off x="457200" y="2148840"/>
+            <a:ext cx="8229600" cy="9144"/>
+          </a:xfrm>
+          <a:prstGeom prst="rect">
+            <a:avLst/>
+          </a:prstGeom>
+          <a:solidFill>
+            <a:srgbClr val="B4B4B4"/>
+          </a:solidFill>
+          <a:ln>
+            <a:noFill/>
           </a:ln>
         </p:spPr>
         <p:style>
@@ -5659,14 +4852,143 @@
       </p:sp>
       <p:sp>
         <p:nvSpPr>
-          <p:cNvPr id="25" name="TextBox 24"/>
+          <p:cNvPr id="9" name="Rectangle 8"/>
+          <p:cNvSpPr/>
+          <p:nvPr/>
+        </p:nvSpPr>
+        <p:spPr>
+          <a:xfrm>
+            <a:off x="457200" y="2560320"/>
+            <a:ext cx="8229600" cy="9144"/>
+          </a:xfrm>
+          <a:prstGeom prst="rect">
+            <a:avLst/>
+          </a:prstGeom>
+          <a:solidFill>
+            <a:srgbClr val="B4B4B4"/>
+          </a:solidFill>
+          <a:ln>
+            <a:noFill/>
+          </a:ln>
+        </p:spPr>
+        <p:style>
+          <a:lnRef idx="1">
+            <a:schemeClr val="accent1"/>
+          </a:lnRef>
+          <a:fillRef idx="3">
+            <a:schemeClr val="accent1"/>
+          </a:fillRef>
+          <a:effectRef idx="2">
+            <a:schemeClr val="accent1"/>
+          </a:effectRef>
+          <a:fontRef idx="minor">
+            <a:schemeClr val="lt1"/>
+          </a:fontRef>
+        </p:style>
+        <p:txBody>
+          <a:bodyPr rtlCol="0" anchor="ctr"/>
+          <a:lstStyle/>
+          <a:p>
+            <a:pPr algn="ctr"/>
+          </a:p>
+        </p:txBody>
+      </p:sp>
+      <p:sp>
+        <p:nvSpPr>
+          <p:cNvPr id="10" name="Rectangle 9"/>
+          <p:cNvSpPr/>
+          <p:nvPr/>
+        </p:nvSpPr>
+        <p:spPr>
+          <a:xfrm>
+            <a:off x="457200" y="2971800"/>
+            <a:ext cx="8229600" cy="9144"/>
+          </a:xfrm>
+          <a:prstGeom prst="rect">
+            <a:avLst/>
+          </a:prstGeom>
+          <a:solidFill>
+            <a:srgbClr val="B4B4B4"/>
+          </a:solidFill>
+          <a:ln>
+            <a:noFill/>
+          </a:ln>
+        </p:spPr>
+        <p:style>
+          <a:lnRef idx="1">
+            <a:schemeClr val="accent1"/>
+          </a:lnRef>
+          <a:fillRef idx="3">
+            <a:schemeClr val="accent1"/>
+          </a:fillRef>
+          <a:effectRef idx="2">
+            <a:schemeClr val="accent1"/>
+          </a:effectRef>
+          <a:fontRef idx="minor">
+            <a:schemeClr val="lt1"/>
+          </a:fontRef>
+        </p:style>
+        <p:txBody>
+          <a:bodyPr rtlCol="0" anchor="ctr"/>
+          <a:lstStyle/>
+          <a:p>
+            <a:pPr algn="ctr"/>
+          </a:p>
+        </p:txBody>
+      </p:sp>
+      <p:sp>
+        <p:nvSpPr>
+          <p:cNvPr id="11" name="Rectangle 10"/>
+          <p:cNvSpPr/>
+          <p:nvPr/>
+        </p:nvSpPr>
+        <p:spPr>
+          <a:xfrm>
+            <a:off x="457200" y="3383280"/>
+            <a:ext cx="8229600" cy="9144"/>
+          </a:xfrm>
+          <a:prstGeom prst="rect">
+            <a:avLst/>
+          </a:prstGeom>
+          <a:solidFill>
+            <a:srgbClr val="B4B4B4"/>
+          </a:solidFill>
+          <a:ln>
+            <a:noFill/>
+          </a:ln>
+        </p:spPr>
+        <p:style>
+          <a:lnRef idx="1">
+            <a:schemeClr val="accent1"/>
+          </a:lnRef>
+          <a:fillRef idx="3">
+            <a:schemeClr val="accent1"/>
+          </a:fillRef>
+          <a:effectRef idx="2">
+            <a:schemeClr val="accent1"/>
+          </a:effectRef>
+          <a:fontRef idx="minor">
+            <a:schemeClr val="lt1"/>
+          </a:fontRef>
+        </p:style>
+        <p:txBody>
+          <a:bodyPr rtlCol="0" anchor="ctr"/>
+          <a:lstStyle/>
+          <a:p>
+            <a:pPr algn="ctr"/>
+          </a:p>
+        </p:txBody>
+      </p:sp>
+      <p:sp>
+        <p:nvSpPr>
+          <p:cNvPr id="12" name="TextBox 11"/>
           <p:cNvSpPr txBox="1"/>
           <p:nvPr/>
         </p:nvSpPr>
         <p:spPr>
           <a:xfrm>
-            <a:off x="640080" y="5212080"/>
-            <a:ext cx="7772400" cy="274320"/>
+            <a:off x="640080" y="2194560"/>
+            <a:ext cx="2103120" cy="228600"/>
           </a:xfrm>
           <a:prstGeom prst="rect">
             <a:avLst/>
@@ -5680,15 +5002,483 @@
           <a:lstStyle/>
           <a:p>
             <a:pPr algn="l">
-              <a:defRPr sz="1200" b="0">
-                <a:solidFill>
-                  <a:srgbClr val="2C3E50"/>
-                </a:solidFill>
-                <a:latin typeface="Calibri"/>
-              </a:defRPr>
-            </a:pPr>
-            <a:r>
-              <a:t>Cost: 1 bit per cell (~6-12 cells typical)</a:t>
+              <a:defRPr sz="1000" b="0">
+                <a:solidFill>
+                  <a:srgbClr val="2C3E50"/>
+                </a:solidFill>
+                <a:latin typeface="Calibri"/>
+              </a:defRPr>
+            </a:pPr>
+            <a:r>
+              <a:t>(2,1) ← A sees A</a:t>
+            </a:r>
+          </a:p>
+        </p:txBody>
+      </p:sp>
+      <p:sp>
+        <p:nvSpPr>
+          <p:cNvPr id="13" name="TextBox 12"/>
+          <p:cNvSpPr txBox="1"/>
+          <p:nvPr/>
+        </p:nvSpPr>
+        <p:spPr>
+          <a:xfrm>
+            <a:off x="2926080" y="2194560"/>
+            <a:ext cx="2286000" cy="228600"/>
+          </a:xfrm>
+          <a:prstGeom prst="rect">
+            <a:avLst/>
+          </a:prstGeom>
+          <a:noFill/>
+        </p:spPr>
+        <p:txBody>
+          <a:bodyPr wrap="square">
+            <a:spAutoFit/>
+          </a:bodyPr>
+          <a:lstStyle/>
+          <a:p>
+            <a:pPr algn="l">
+              <a:defRPr sz="1000" b="0">
+                <a:solidFill>
+                  <a:srgbClr val="2C3E50"/>
+                </a:solidFill>
+                <a:latin typeface="Calibri"/>
+              </a:defRPr>
+            </a:pPr>
+            <a:r>
+              <a:t>bit=0 "A vouches"</a:t>
+            </a:r>
+          </a:p>
+        </p:txBody>
+      </p:sp>
+      <p:sp>
+        <p:nvSpPr>
+          <p:cNvPr id="14" name="TextBox 13"/>
+          <p:cNvSpPr txBox="1"/>
+          <p:nvPr/>
+        </p:nvSpPr>
+        <p:spPr>
+          <a:xfrm>
+            <a:off x="5669280" y="2194560"/>
+            <a:ext cx="2286000" cy="228600"/>
+          </a:xfrm>
+          <a:prstGeom prst="rect">
+            <a:avLst/>
+          </a:prstGeom>
+          <a:noFill/>
+        </p:spPr>
+        <p:txBody>
+          <a:bodyPr wrap="square">
+            <a:spAutoFit/>
+          </a:bodyPr>
+          <a:lstStyle/>
+          <a:p>
+            <a:pPr algn="l">
+              <a:defRPr sz="1000" b="0">
+                <a:solidFill>
+                  <a:srgbClr val="2C3E50"/>
+                </a:solidFill>
+                <a:latin typeface="Calibri"/>
+              </a:defRPr>
+            </a:pPr>
+            <a:r>
+              <a:t>Accept if:</a:t>
+            </a:r>
+          </a:p>
+        </p:txBody>
+      </p:sp>
+      <p:sp>
+        <p:nvSpPr>
+          <p:cNvPr id="15" name="TextBox 14"/>
+          <p:cNvSpPr txBox="1"/>
+          <p:nvPr/>
+        </p:nvSpPr>
+        <p:spPr>
+          <a:xfrm>
+            <a:off x="640080" y="2606040"/>
+            <a:ext cx="2103120" cy="228600"/>
+          </a:xfrm>
+          <a:prstGeom prst="rect">
+            <a:avLst/>
+          </a:prstGeom>
+          <a:noFill/>
+        </p:spPr>
+        <p:txBody>
+          <a:bodyPr wrap="square">
+            <a:spAutoFit/>
+          </a:bodyPr>
+          <a:lstStyle/>
+          <a:p>
+            <a:pPr algn="l">
+              <a:defRPr sz="1000" b="0">
+                <a:solidFill>
+                  <a:srgbClr val="2C3E50"/>
+                </a:solidFill>
+                <a:latin typeface="Calibri"/>
+              </a:defRPr>
+            </a:pPr>
+            <a:r>
+              <a:t>(2,2) ← A sees A</a:t>
+            </a:r>
+          </a:p>
+        </p:txBody>
+      </p:sp>
+      <p:sp>
+        <p:nvSpPr>
+          <p:cNvPr id="16" name="TextBox 15"/>
+          <p:cNvSpPr txBox="1"/>
+          <p:nvPr/>
+        </p:nvSpPr>
+        <p:spPr>
+          <a:xfrm>
+            <a:off x="2926080" y="2606040"/>
+            <a:ext cx="2286000" cy="228600"/>
+          </a:xfrm>
+          <a:prstGeom prst="rect">
+            <a:avLst/>
+          </a:prstGeom>
+          <a:noFill/>
+        </p:spPr>
+        <p:txBody>
+          <a:bodyPr wrap="square">
+            <a:spAutoFit/>
+          </a:bodyPr>
+          <a:lstStyle/>
+          <a:p>
+            <a:pPr algn="l">
+              <a:defRPr sz="1000" b="0">
+                <a:solidFill>
+                  <a:srgbClr val="2C3E50"/>
+                </a:solidFill>
+                <a:latin typeface="Calibri"/>
+              </a:defRPr>
+            </a:pPr>
+            <a:r>
+              <a:t>bit=0 "A vouches"</a:t>
+            </a:r>
+          </a:p>
+        </p:txBody>
+      </p:sp>
+      <p:sp>
+        <p:nvSpPr>
+          <p:cNvPr id="17" name="TextBox 16"/>
+          <p:cNvSpPr txBox="1"/>
+          <p:nvPr/>
+        </p:nvSpPr>
+        <p:spPr>
+          <a:xfrm>
+            <a:off x="5669280" y="2606040"/>
+            <a:ext cx="2286000" cy="228600"/>
+          </a:xfrm>
+          <a:prstGeom prst="rect">
+            <a:avLst/>
+          </a:prstGeom>
+          <a:noFill/>
+        </p:spPr>
+        <p:txBody>
+          <a:bodyPr wrap="square">
+            <a:spAutoFit/>
+          </a:bodyPr>
+          <a:lstStyle/>
+          <a:p>
+            <a:pPr algn="l">
+              <a:defRPr sz="1000" b="0">
+                <a:solidFill>
+                  <a:srgbClr val="2C3E50"/>
+                </a:solidFill>
+                <a:latin typeface="Calibri"/>
+              </a:defRPr>
+            </a:pPr>
+            <a:r>
+              <a:t>- B sees blocked</a:t>
+            </a:r>
+          </a:p>
+        </p:txBody>
+      </p:sp>
+      <p:sp>
+        <p:nvSpPr>
+          <p:cNvPr id="18" name="TextBox 17"/>
+          <p:cNvSpPr txBox="1"/>
+          <p:nvPr/>
+        </p:nvSpPr>
+        <p:spPr>
+          <a:xfrm>
+            <a:off x="640080" y="3017520"/>
+            <a:ext cx="2103120" cy="228600"/>
+          </a:xfrm>
+          <a:prstGeom prst="rect">
+            <a:avLst/>
+          </a:prstGeom>
+          <a:noFill/>
+        </p:spPr>
+        <p:txBody>
+          <a:bodyPr wrap="square">
+            <a:spAutoFit/>
+          </a:bodyPr>
+          <a:lstStyle/>
+          <a:p>
+            <a:pPr algn="l">
+              <a:defRPr sz="1000" b="0">
+                <a:solidFill>
+                  <a:srgbClr val="2C3E50"/>
+                </a:solidFill>
+                <a:latin typeface="Calibri"/>
+              </a:defRPr>
+            </a:pPr>
+            <a:r>
+              <a:t>(2,3) ← A sees A</a:t>
+            </a:r>
+          </a:p>
+        </p:txBody>
+      </p:sp>
+      <p:sp>
+        <p:nvSpPr>
+          <p:cNvPr id="19" name="TextBox 18"/>
+          <p:cNvSpPr txBox="1"/>
+          <p:nvPr/>
+        </p:nvSpPr>
+        <p:spPr>
+          <a:xfrm>
+            <a:off x="2926080" y="3017520"/>
+            <a:ext cx="2286000" cy="228600"/>
+          </a:xfrm>
+          <a:prstGeom prst="rect">
+            <a:avLst/>
+          </a:prstGeom>
+          <a:noFill/>
+        </p:spPr>
+        <p:txBody>
+          <a:bodyPr wrap="square">
+            <a:spAutoFit/>
+          </a:bodyPr>
+          <a:lstStyle/>
+          <a:p>
+            <a:pPr algn="l">
+              <a:defRPr sz="1000" b="0">
+                <a:solidFill>
+                  <a:srgbClr val="27AE60"/>
+                </a:solidFill>
+                <a:latin typeface="Calibri"/>
+              </a:defRPr>
+            </a:pPr>
+            <a:r>
+              <a:t>bit=1 "B vouches"</a:t>
+            </a:r>
+          </a:p>
+        </p:txBody>
+      </p:sp>
+      <p:sp>
+        <p:nvSpPr>
+          <p:cNvPr id="20" name="TextBox 19"/>
+          <p:cNvSpPr txBox="1"/>
+          <p:nvPr/>
+        </p:nvSpPr>
+        <p:spPr>
+          <a:xfrm>
+            <a:off x="5669280" y="3017520"/>
+            <a:ext cx="2286000" cy="228600"/>
+          </a:xfrm>
+          <a:prstGeom prst="rect">
+            <a:avLst/>
+          </a:prstGeom>
+          <a:noFill/>
+        </p:spPr>
+        <p:txBody>
+          <a:bodyPr wrap="square">
+            <a:spAutoFit/>
+          </a:bodyPr>
+          <a:lstStyle/>
+          <a:p>
+            <a:pPr algn="l">
+              <a:defRPr sz="1000" b="1">
+                <a:solidFill>
+                  <a:srgbClr val="2C3E50"/>
+                </a:solidFill>
+                <a:latin typeface="Calibri"/>
+              </a:defRPr>
+            </a:pPr>
+            <a:r>
+              <a:t>OR</a:t>
+            </a:r>
+          </a:p>
+        </p:txBody>
+      </p:sp>
+      <p:sp>
+        <p:nvSpPr>
+          <p:cNvPr id="21" name="TextBox 20"/>
+          <p:cNvSpPr txBox="1"/>
+          <p:nvPr/>
+        </p:nvSpPr>
+        <p:spPr>
+          <a:xfrm>
+            <a:off x="640080" y="3429000"/>
+            <a:ext cx="2103120" cy="228600"/>
+          </a:xfrm>
+          <a:prstGeom prst="rect">
+            <a:avLst/>
+          </a:prstGeom>
+          <a:noFill/>
+        </p:spPr>
+        <p:txBody>
+          <a:bodyPr wrap="square">
+            <a:spAutoFit/>
+          </a:bodyPr>
+          <a:lstStyle/>
+          <a:p>
+            <a:pPr algn="l">
+              <a:defRPr sz="1000" b="0">
+                <a:solidFill>
+                  <a:srgbClr val="2C3E50"/>
+                </a:solidFill>
+                <a:latin typeface="Calibri"/>
+              </a:defRPr>
+            </a:pPr>
+            <a:r>
+              <a:t>(2,4) ← A sees .</a:t>
+            </a:r>
+          </a:p>
+        </p:txBody>
+      </p:sp>
+      <p:sp>
+        <p:nvSpPr>
+          <p:cNvPr id="22" name="TextBox 21"/>
+          <p:cNvSpPr txBox="1"/>
+          <p:nvPr/>
+        </p:nvSpPr>
+        <p:spPr>
+          <a:xfrm>
+            <a:off x="2926080" y="3429000"/>
+            <a:ext cx="2286000" cy="228600"/>
+          </a:xfrm>
+          <a:prstGeom prst="rect">
+            <a:avLst/>
+          </a:prstGeom>
+          <a:noFill/>
+        </p:spPr>
+        <p:txBody>
+          <a:bodyPr wrap="square">
+            <a:spAutoFit/>
+          </a:bodyPr>
+          <a:lstStyle/>
+          <a:p>
+            <a:pPr algn="l">
+              <a:defRPr sz="1000" b="0">
+                <a:solidFill>
+                  <a:srgbClr val="27AE60"/>
+                </a:solidFill>
+                <a:latin typeface="Calibri"/>
+              </a:defRPr>
+            </a:pPr>
+            <a:r>
+              <a:t>bit=1 "B vouches"</a:t>
+            </a:r>
+          </a:p>
+        </p:txBody>
+      </p:sp>
+      <p:sp>
+        <p:nvSpPr>
+          <p:cNvPr id="23" name="TextBox 22"/>
+          <p:cNvSpPr txBox="1"/>
+          <p:nvPr/>
+        </p:nvSpPr>
+        <p:spPr>
+          <a:xfrm>
+            <a:off x="5669280" y="3429000"/>
+            <a:ext cx="2286000" cy="228600"/>
+          </a:xfrm>
+          <a:prstGeom prst="rect">
+            <a:avLst/>
+          </a:prstGeom>
+          <a:noFill/>
+        </p:spPr>
+        <p:txBody>
+          <a:bodyPr wrap="square">
+            <a:spAutoFit/>
+          </a:bodyPr>
+          <a:lstStyle/>
+          <a:p>
+            <a:pPr algn="l">
+              <a:defRPr sz="1000" b="0">
+                <a:solidFill>
+                  <a:srgbClr val="2C3E50"/>
+                </a:solidFill>
+                <a:latin typeface="Calibri"/>
+              </a:defRPr>
+            </a:pPr>
+            <a:r>
+              <a:t>- bit=0</a:t>
+            </a:r>
+          </a:p>
+        </p:txBody>
+      </p:sp>
+      <p:sp>
+        <p:nvSpPr>
+          <p:cNvPr id="24" name="TextBox 23"/>
+          <p:cNvSpPr txBox="1"/>
+          <p:nvPr/>
+        </p:nvSpPr>
+        <p:spPr>
+          <a:xfrm>
+            <a:off x="4114800" y="3931920"/>
+            <a:ext cx="914400" cy="274320"/>
+          </a:xfrm>
+          <a:prstGeom prst="rect">
+            <a:avLst/>
+          </a:prstGeom>
+          <a:noFill/>
+        </p:spPr>
+        <p:txBody>
+          <a:bodyPr wrap="square">
+            <a:spAutoFit/>
+          </a:bodyPr>
+          <a:lstStyle/>
+          <a:p>
+            <a:pPr algn="ctr">
+              <a:defRPr sz="2400" b="0">
+                <a:solidFill>
+                  <a:srgbClr val="F39C12"/>
+                </a:solidFill>
+                <a:latin typeface="Calibri"/>
+              </a:defRPr>
+            </a:pPr>
+            <a:r>
+              <a:t>⇓</a:t>
+            </a:r>
+          </a:p>
+        </p:txBody>
+      </p:sp>
+      <p:sp>
+        <p:nvSpPr>
+          <p:cNvPr id="25" name="TextBox 24"/>
+          <p:cNvSpPr txBox="1"/>
+          <p:nvPr/>
+        </p:nvSpPr>
+        <p:spPr>
+          <a:xfrm>
+            <a:off x="1371600" y="4297680"/>
+            <a:ext cx="4572000" cy="228600"/>
+          </a:xfrm>
+          <a:prstGeom prst="rect">
+            <a:avLst/>
+          </a:prstGeom>
+          <a:noFill/>
+        </p:spPr>
+        <p:txBody>
+          <a:bodyPr wrap="square">
+            <a:spAutoFit/>
+          </a:bodyPr>
+          <a:lstStyle/>
+          <a:p>
+            <a:pPr algn="l">
+              <a:defRPr sz="1100" b="0">
+                <a:solidFill>
+                  <a:srgbClr val="27AE60"/>
+                </a:solidFill>
+                <a:latin typeface="Calibri"/>
+              </a:defRPr>
+            </a:pPr>
+            <a:r>
+              <a:t>B checks (2,3): B sees blocked  ✓ Accept</a:t>
             </a:r>
           </a:p>
         </p:txBody>
@@ -5701,7 +5491,158 @@
         </p:nvSpPr>
         <p:spPr>
           <a:xfrm>
+            <a:off x="1371600" y="4572000"/>
+            <a:ext cx="4572000" cy="228600"/>
+          </a:xfrm>
+          <a:prstGeom prst="rect">
+            <a:avLst/>
+          </a:prstGeom>
+          <a:noFill/>
+        </p:spPr>
+        <p:txBody>
+          <a:bodyPr wrap="square">
+            <a:spAutoFit/>
+          </a:bodyPr>
+          <a:lstStyle/>
+          <a:p>
+            <a:pPr algn="l">
+              <a:defRPr sz="1100" b="0">
+                <a:solidFill>
+                  <a:srgbClr val="27AE60"/>
+                </a:solidFill>
+                <a:latin typeface="Calibri"/>
+              </a:defRPr>
+            </a:pPr>
+            <a:r>
+              <a:t>B checks (2,4): B sees blocked  ✓ Accept</a:t>
+            </a:r>
+          </a:p>
+        </p:txBody>
+      </p:sp>
+      <p:sp>
+        <p:nvSpPr>
+          <p:cNvPr id="27" name="TextBox 26"/>
+          <p:cNvSpPr txBox="1"/>
+          <p:nvPr/>
+        </p:nvSpPr>
+        <p:spPr>
+          <a:xfrm>
+            <a:off x="1371600" y="4937760"/>
+            <a:ext cx="5486400" cy="274320"/>
+          </a:xfrm>
+          <a:prstGeom prst="rect">
+            <a:avLst/>
+          </a:prstGeom>
+          <a:noFill/>
+        </p:spPr>
+        <p:txBody>
+          <a:bodyPr wrap="square">
+            <a:spAutoFit/>
+          </a:bodyPr>
+          <a:lstStyle/>
+          <a:p>
+            <a:pPr algn="l">
+              <a:defRPr sz="1100" b="0">
+                <a:solidFill>
+                  <a:srgbClr val="E74C3C"/>
+                </a:solidFill>
+                <a:latin typeface="Calibri"/>
+              </a:defRPr>
+            </a:pPr>
+            <a:r>
+              <a:t>If witness=1 but B sees free → NACK → PROBE</a:t>
+            </a:r>
+          </a:p>
+        </p:txBody>
+      </p:sp>
+      <p:sp>
+        <p:nvSpPr>
+          <p:cNvPr id="28" name="Rectangle 27"/>
+          <p:cNvSpPr/>
+          <p:nvPr/>
+        </p:nvSpPr>
+        <p:spPr>
+          <a:xfrm>
+            <a:off x="457200" y="5394960"/>
+            <a:ext cx="8229600" cy="1188720"/>
+          </a:xfrm>
+          <a:prstGeom prst="rect">
+            <a:avLst/>
+          </a:prstGeom>
+          <a:noFill/>
+          <a:ln w="25400">
+            <a:solidFill>
+              <a:srgbClr val="F39C12"/>
+            </a:solidFill>
+          </a:ln>
+        </p:spPr>
+        <p:style>
+          <a:lnRef idx="1">
+            <a:schemeClr val="accent1"/>
+          </a:lnRef>
+          <a:fillRef idx="3">
+            <a:schemeClr val="accent1"/>
+          </a:fillRef>
+          <a:effectRef idx="2">
+            <a:schemeClr val="accent1"/>
+          </a:effectRef>
+          <a:fontRef idx="minor">
+            <a:schemeClr val="lt1"/>
+          </a:fontRef>
+        </p:style>
+        <p:txBody>
+          <a:bodyPr rtlCol="0" anchor="ctr"/>
+          <a:lstStyle/>
+          <a:p>
+            <a:pPr algn="ctr"/>
+          </a:p>
+        </p:txBody>
+      </p:sp>
+      <p:sp>
+        <p:nvSpPr>
+          <p:cNvPr id="29" name="TextBox 28"/>
+          <p:cNvSpPr txBox="1"/>
+          <p:nvPr/>
+        </p:nvSpPr>
+        <p:spPr>
+          <a:xfrm>
             <a:off x="640080" y="5577840"/>
+            <a:ext cx="7772400" cy="274320"/>
+          </a:xfrm>
+          <a:prstGeom prst="rect">
+            <a:avLst/>
+          </a:prstGeom>
+          <a:noFill/>
+        </p:spPr>
+        <p:txBody>
+          <a:bodyPr wrap="square">
+            <a:spAutoFit/>
+          </a:bodyPr>
+          <a:lstStyle/>
+          <a:p>
+            <a:pPr algn="l">
+              <a:defRPr sz="1200" b="0">
+                <a:solidFill>
+                  <a:srgbClr val="2C3E50"/>
+                </a:solidFill>
+                <a:latin typeface="Calibri"/>
+              </a:defRPr>
+            </a:pPr>
+            <a:r>
+              <a:t>Cost: 1 bit per cell (~6-12 cells typical)</a:t>
+            </a:r>
+          </a:p>
+        </p:txBody>
+      </p:sp>
+      <p:sp>
+        <p:nvSpPr>
+          <p:cNvPr id="30" name="TextBox 29"/>
+          <p:cNvSpPr txBox="1"/>
+          <p:nvPr/>
+        </p:nvSpPr>
+        <p:spPr>
+          <a:xfrm>
+            <a:off x="640080" y="5943600"/>
             <a:ext cx="7772400" cy="365760"/>
           </a:xfrm>
           <a:prstGeom prst="rect">
@@ -6396,7 +6337,7 @@
               </a:defRPr>
             </a:pPr>
             <a:r>
-              <a:t>↓</a:t>
+              <a:t>⇓</a:t>
             </a:r>
           </a:p>
           <a:p>
@@ -6435,7 +6376,7 @@
               </a:defRPr>
             </a:pPr>
             <a:r>
-              <a:t>↓</a:t>
+              <a:t>⇓</a:t>
             </a:r>
           </a:p>
           <a:p>
@@ -6497,8 +6438,8 @@
         </p:nvSpPr>
         <p:spPr>
           <a:xfrm>
-            <a:off x="2468880" y="1188720"/>
-            <a:ext cx="2286000" cy="2103120"/>
+            <a:off x="2468880" y="1097280"/>
+            <a:ext cx="2743200" cy="2560320"/>
           </a:xfrm>
           <a:prstGeom prst="rect">
             <a:avLst/>
@@ -6542,8 +6483,8 @@
         </p:nvSpPr>
         <p:spPr>
           <a:xfrm>
-            <a:off x="2560320" y="1280160"/>
-            <a:ext cx="2103120" cy="274320"/>
+            <a:off x="2606040" y="1234440"/>
+            <a:ext cx="2468880" cy="320040"/>
           </a:xfrm>
           <a:prstGeom prst="rect">
             <a:avLst/>
@@ -6557,7 +6498,7 @@
           <a:lstStyle/>
           <a:p>
             <a:pPr algn="l">
-              <a:defRPr sz="1400" b="1">
+              <a:defRPr sz="1500" b="1">
                 <a:solidFill>
                   <a:srgbClr val="F39C12"/>
                 </a:solidFill>
@@ -6578,8 +6519,8 @@
         </p:nvSpPr>
         <p:spPr>
           <a:xfrm>
-            <a:off x="2560320" y="1554480"/>
-            <a:ext cx="2103120" cy="228600"/>
+            <a:off x="2606040" y="1554480"/>
+            <a:ext cx="2468880" cy="228600"/>
           </a:xfrm>
           <a:prstGeom prst="rect">
             <a:avLst/>
@@ -6614,8 +6555,8 @@
         </p:nvSpPr>
         <p:spPr>
           <a:xfrm>
-            <a:off x="2651760" y="1828800"/>
-            <a:ext cx="1920240" cy="1371600"/>
+            <a:off x="2697480" y="1828800"/>
+            <a:ext cx="2286000" cy="1645920"/>
           </a:xfrm>
           <a:prstGeom prst="rect">
             <a:avLst/>
@@ -6689,7 +6630,7 @@
               </a:defRPr>
             </a:pPr>
             <a:r>
-              <a:t>↓</a:t>
+              <a:t>⇓</a:t>
             </a:r>
           </a:p>
           <a:p>
@@ -6728,7 +6669,7 @@
               </a:defRPr>
             </a:pPr>
             <a:r>
-              <a:t>↓</a:t>
+              <a:t>⇓</a:t>
             </a:r>
           </a:p>
           <a:p>
@@ -6803,7 +6744,7 @@
         </p:nvSpPr>
         <p:spPr>
           <a:xfrm>
-            <a:off x="4937760" y="1188720"/>
+            <a:off x="5486400" y="1188720"/>
             <a:ext cx="2011680" cy="2103120"/>
           </a:xfrm>
           <a:prstGeom prst="rect">
@@ -6848,7 +6789,7 @@
         </p:nvSpPr>
         <p:spPr>
           <a:xfrm>
-            <a:off x="5029200" y="1280160"/>
+            <a:off x="5577840" y="1280160"/>
             <a:ext cx="1828800" cy="274320"/>
           </a:xfrm>
           <a:prstGeom prst="rect">
@@ -6884,7 +6825,7 @@
         </p:nvSpPr>
         <p:spPr>
           <a:xfrm>
-            <a:off x="5120640" y="1645920"/>
+            <a:off x="5669280" y="1645920"/>
             <a:ext cx="1645920" cy="1463040"/>
           </a:xfrm>
           <a:prstGeom prst="rect">
@@ -6946,7 +6887,7 @@
               </a:defRPr>
             </a:pPr>
             <a:r>
-              <a:t>↓</a:t>
+              <a:t>⇓</a:t>
             </a:r>
           </a:p>
           <a:p>
@@ -7021,8 +6962,8 @@
         </p:nvSpPr>
         <p:spPr>
           <a:xfrm>
-            <a:off x="274320" y="3474720"/>
-            <a:ext cx="2286000" cy="2103120"/>
+            <a:off x="274320" y="3840480"/>
+            <a:ext cx="2560320" cy="2103120"/>
           </a:xfrm>
           <a:prstGeom prst="rect">
             <a:avLst/>
@@ -7066,8 +7007,8 @@
         </p:nvSpPr>
         <p:spPr>
           <a:xfrm>
-            <a:off x="365760" y="3566160"/>
-            <a:ext cx="2103120" cy="274320"/>
+            <a:off x="365760" y="3931920"/>
+            <a:ext cx="2377440" cy="274320"/>
           </a:xfrm>
           <a:prstGeom prst="rect">
             <a:avLst/>
@@ -7089,7 +7030,7 @@
               </a:defRPr>
             </a:pPr>
             <a:r>
-              <a:t>Responder-</a:t>
+              <a:t>Responder-MinCut</a:t>
             </a:r>
           </a:p>
         </p:txBody>
@@ -7102,8 +7043,8 @@
         </p:nvSpPr>
         <p:spPr>
           <a:xfrm>
-            <a:off x="365760" y="3840480"/>
-            <a:ext cx="2103120" cy="274320"/>
+            <a:off x="457200" y="4297680"/>
+            <a:ext cx="2194560" cy="1463040"/>
           </a:xfrm>
           <a:prstGeom prst="rect">
             <a:avLst/>
@@ -7117,15 +7058,103 @@
           <a:lstStyle/>
           <a:p>
             <a:pPr algn="l">
-              <a:defRPr sz="1300" b="1">
-                <a:solidFill>
-                  <a:srgbClr val="2C3E50"/>
-                </a:solidFill>
-                <a:latin typeface="Calibri"/>
-              </a:defRPr>
-            </a:pPr>
-            <a:r>
-              <a:t>MinCut</a:t>
+              <a:defRPr sz="1000" b="0">
+                <a:solidFill>
+                  <a:srgbClr val="2C3E50"/>
+                </a:solidFill>
+                <a:latin typeface="Calibri"/>
+              </a:defRPr>
+            </a:pPr>
+            <a:r>
+              <a:t>B: leads</a:t>
+            </a:r>
+          </a:p>
+          <a:p>
+            <a:pPr algn="l">
+              <a:defRPr sz="1000" b="0">
+                <a:solidFill>
+                  <a:srgbClr val="2C3E50"/>
+                </a:solidFill>
+                <a:latin typeface="Calibri"/>
+              </a:defRPr>
+            </a:pPr>
+            <a:r>
+              <a:t>with cut</a:t>
+            </a:r>
+          </a:p>
+          <a:p>
+            <a:pPr algn="l">
+              <a:defRPr sz="1000" b="0">
+                <a:solidFill>
+                  <a:srgbClr val="2C3E50"/>
+                </a:solidFill>
+                <a:latin typeface="Calibri"/>
+              </a:defRPr>
+            </a:pPr>
+            <a:r>
+              <a:t>⇓</a:t>
+            </a:r>
+          </a:p>
+          <a:p>
+            <a:pPr algn="l">
+              <a:defRPr sz="1000" b="0">
+                <a:solidFill>
+                  <a:srgbClr val="2C3E50"/>
+                </a:solidFill>
+                <a:latin typeface="Calibri"/>
+              </a:defRPr>
+            </a:pPr>
+            <a:r>
+              <a:t>A: probes</a:t>
+            </a:r>
+          </a:p>
+          <a:p>
+            <a:pPr algn="l">
+              <a:defRPr sz="1000" b="0">
+                <a:solidFill>
+                  <a:srgbClr val="2C3E50"/>
+                </a:solidFill>
+                <a:latin typeface="Calibri"/>
+              </a:defRPr>
+            </a:pPr>
+            <a:r>
+              <a:t>conflicts</a:t>
+            </a:r>
+          </a:p>
+          <a:p>
+            <a:pPr algn="l">
+              <a:defRPr sz="1000" b="0">
+                <a:solidFill>
+                  <a:srgbClr val="2C3E50"/>
+                </a:solidFill>
+                <a:latin typeface="Calibri"/>
+              </a:defRPr>
+            </a:pPr>
+          </a:p>
+          <a:p>
+            <a:pPr algn="l">
+              <a:defRPr sz="1000" b="0">
+                <a:solidFill>
+                  <a:srgbClr val="2C3E50"/>
+                </a:solidFill>
+                <a:latin typeface="Calibri"/>
+              </a:defRPr>
+            </a:pPr>
+            <a:r>
+              <a:t>Cut-only</a:t>
+            </a:r>
+          </a:p>
+          <a:p>
+            <a:pPr algn="l">
+              <a:defRPr sz="1000" b="0">
+                <a:solidFill>
+                  <a:srgbClr val="2C3E50"/>
+                </a:solidFill>
+                <a:latin typeface="Calibri"/>
+              </a:defRPr>
+            </a:pPr>
+            <a:r>
+              <a:t>(unreach)</a:t>
             </a:r>
           </a:p>
         </p:txBody>
@@ -7138,131 +7167,7 @@
         </p:nvSpPr>
         <p:spPr>
           <a:xfrm>
-            <a:off x="457200" y="4206240"/>
-            <a:ext cx="1920240" cy="1280160"/>
-          </a:xfrm>
-          <a:prstGeom prst="rect">
-            <a:avLst/>
-          </a:prstGeom>
-          <a:noFill/>
-        </p:spPr>
-        <p:txBody>
-          <a:bodyPr wrap="square">
-            <a:spAutoFit/>
-          </a:bodyPr>
-          <a:lstStyle/>
-          <a:p>
-            <a:pPr algn="l">
-              <a:defRPr sz="1000" b="0">
-                <a:solidFill>
-                  <a:srgbClr val="2C3E50"/>
-                </a:solidFill>
-                <a:latin typeface="Calibri"/>
-              </a:defRPr>
-            </a:pPr>
-            <a:r>
-              <a:t>B: leads</a:t>
-            </a:r>
-          </a:p>
-          <a:p>
-            <a:pPr algn="l">
-              <a:defRPr sz="1000" b="0">
-                <a:solidFill>
-                  <a:srgbClr val="2C3E50"/>
-                </a:solidFill>
-                <a:latin typeface="Calibri"/>
-              </a:defRPr>
-            </a:pPr>
-            <a:r>
-              <a:t>with cut</a:t>
-            </a:r>
-          </a:p>
-          <a:p>
-            <a:pPr algn="l">
-              <a:defRPr sz="1000" b="0">
-                <a:solidFill>
-                  <a:srgbClr val="2C3E50"/>
-                </a:solidFill>
-                <a:latin typeface="Calibri"/>
-              </a:defRPr>
-            </a:pPr>
-            <a:r>
-              <a:t>↓</a:t>
-            </a:r>
-          </a:p>
-          <a:p>
-            <a:pPr algn="l">
-              <a:defRPr sz="1000" b="0">
-                <a:solidFill>
-                  <a:srgbClr val="2C3E50"/>
-                </a:solidFill>
-                <a:latin typeface="Calibri"/>
-              </a:defRPr>
-            </a:pPr>
-            <a:r>
-              <a:t>A: probes</a:t>
-            </a:r>
-          </a:p>
-          <a:p>
-            <a:pPr algn="l">
-              <a:defRPr sz="1000" b="0">
-                <a:solidFill>
-                  <a:srgbClr val="2C3E50"/>
-                </a:solidFill>
-                <a:latin typeface="Calibri"/>
-              </a:defRPr>
-            </a:pPr>
-            <a:r>
-              <a:t>conflicts</a:t>
-            </a:r>
-          </a:p>
-          <a:p>
-            <a:pPr algn="l">
-              <a:defRPr sz="1000" b="0">
-                <a:solidFill>
-                  <a:srgbClr val="2C3E50"/>
-                </a:solidFill>
-                <a:latin typeface="Calibri"/>
-              </a:defRPr>
-            </a:pPr>
-          </a:p>
-          <a:p>
-            <a:pPr algn="l">
-              <a:defRPr sz="1000" b="0">
-                <a:solidFill>
-                  <a:srgbClr val="2C3E50"/>
-                </a:solidFill>
-                <a:latin typeface="Calibri"/>
-              </a:defRPr>
-            </a:pPr>
-            <a:r>
-              <a:t>Cut-only</a:t>
-            </a:r>
-          </a:p>
-          <a:p>
-            <a:pPr algn="l">
-              <a:defRPr sz="1000" b="0">
-                <a:solidFill>
-                  <a:srgbClr val="2C3E50"/>
-                </a:solidFill>
-                <a:latin typeface="Calibri"/>
-              </a:defRPr>
-            </a:pPr>
-            <a:r>
-              <a:t>(unreach)</a:t>
-            </a:r>
-          </a:p>
-        </p:txBody>
-      </p:sp>
-      <p:sp>
-        <p:nvSpPr>
-          <p:cNvPr id="17" name="TextBox 16"/>
-          <p:cNvSpPr txBox="1"/>
-          <p:nvPr/>
-        </p:nvSpPr>
-        <p:spPr>
-          <a:xfrm>
-            <a:off x="914400" y="5943600"/>
+            <a:off x="914400" y="6217920"/>
             <a:ext cx="7315200" cy="365760"/>
           </a:xfrm>
           <a:prstGeom prst="rect">

</xml_diff>